<commit_message>
Add Dangote logo to title slide; ship PDF; compress package
- Logo placed on the title slide. The mark is navy on transparent, so it
  sits on a white plate rather than disappearing into the navy slide.
- Build auto-trims the logo's surrounding margin via sharp, so any supplied
  file fills its box predictably; falls back to the untrimmed original if
  sharp is unavailable.
- Repack the .pptx with deflate. pptxgenjs stores zip entries uncompressed,
  which left the deck 810 KB; it is now 122 KB with identical content.
- Commit dist/CDU-Integrity-Group-C.pdf as a deliverable alongside the .pptx.

Co-Authored-By: Claude Opus 5 <noreply@anthropic.com>
Claude-Session: https://claude.ai/code/session_012JNFPJ8e9vZ7bL5qKTKjPz
</commit_message>
<xml_diff>
--- a/dist/CDU-Integrity-Group-C.pptx
+++ b/dist/CDU-Integrity-Group-C.pptx
@@ -2773,89 +2773,45 @@
         <p:spPr>
           <a:xfrm>
             <a:off x="566928" y="566928"/>
-            <a:ext cx="2286000" cy="960120"/>
+            <a:ext cx="2194560" cy="1207008"/>
           </a:xfrm>
           <a:prstGeom prst="roundRect">
             <a:avLst>
-              <a:gd name="adj" fmla="val 5714"/>
+              <a:gd name="adj" fmla="val 3788"/>
             </a:avLst>
           </a:prstGeom>
           <a:solidFill>
-            <a:srgbClr val="12395F"/>
+            <a:srgbClr val="FFFFFF"/>
           </a:solidFill>
-          <a:ln w="12700">
-            <a:solidFill>
-              <a:srgbClr val="45688C"/>
-            </a:solidFill>
-            <a:prstDash val="dash"/>
-          </a:ln>
-        </p:spPr>
-      </p:sp>
-      <p:sp>
-        <p:nvSpPr>
-          <p:cNvPr id="3" name="Text 1"/>
-          <p:cNvSpPr/>
-          <p:nvPr/>
-        </p:nvSpPr>
-        <p:spPr>
-          <a:xfrm>
-            <a:off x="566928" y="566928"/>
-            <a:ext cx="2286000" cy="960120"/>
-          </a:xfrm>
-          <a:prstGeom prst="rect">
-            <a:avLst/>
-          </a:prstGeom>
-          <a:noFill/>
-          <a:ln/>
-        </p:spPr>
-        <p:txBody>
-          <a:bodyPr wrap="square" lIns="0" tIns="0" rIns="0" bIns="0" rtlCol="0" anchor="ctr"/>
-          <a:lstStyle/>
-          <a:p>
-            <a:pPr algn="ctr" indent="0" marL="0">
-              <a:lnSpc>
-                <a:spcPts val="1300"/>
-              </a:lnSpc>
-              <a:buNone/>
-            </a:pPr>
-            <a:r>
-              <a:rPr lang="en-US" sz="950" dirty="0">
-                <a:solidFill>
-                  <a:srgbClr val="8FB0CE"/>
-                </a:solidFill>
-                <a:latin typeface="Calibri" pitchFamily="34" charset="0"/>
-                <a:ea typeface="Calibri" pitchFamily="34" charset="-122"/>
-                <a:cs typeface="Calibri" pitchFamily="34" charset="-120"/>
-              </a:rPr>
-              <a:t>DANGOTE LOGO</a:t>
-            </a:r>
-            <a:endParaRPr lang="en-US" sz="950" dirty="0"/>
-          </a:p>
-          <a:p>
-            <a:pPr algn="ctr" indent="0" marL="0">
-              <a:lnSpc>
-                <a:spcPts val="1300"/>
-              </a:lnSpc>
-              <a:buNone/>
-            </a:pPr>
-            <a:r>
-              <a:rPr lang="en-US" sz="950" dirty="0">
-                <a:solidFill>
-                  <a:srgbClr val="8FB0CE"/>
-                </a:solidFill>
-                <a:latin typeface="Calibri" pitchFamily="34" charset="0"/>
-                <a:ea typeface="Calibri" pitchFamily="34" charset="-122"/>
-                <a:cs typeface="Calibri" pitchFamily="34" charset="-120"/>
-              </a:rPr>
-              <a:t>place assets/dangote-logo.png</a:t>
-            </a:r>
-            <a:endParaRPr lang="en-US" sz="950" dirty="0"/>
-          </a:p>
-        </p:txBody>
-      </p:sp>
-      <p:sp>
-        <p:nvSpPr>
-          <p:cNvPr id="4" name="Text 2"/>
+          <a:ln/>
+        </p:spPr>
+      </p:sp>
+      <p:pic>
+        <p:nvPicPr>
+          <p:cNvPr id="3" name="Image 0" descr="/home/user/Automations/assets/.logo-trimmed.png">    </p:cNvPr>
+          <p:cNvPicPr>
+            <a:picLocks noChangeAspect="1"/>
+          </p:cNvPicPr>
+          <p:nvPr/>
+        </p:nvPicPr>
+        <p:blipFill>
+          <a:blip r:embed="rId1"/>
+          <a:srcRect l="0" r="0" t="0" b="0"/>
+          <a:stretch/>
+        </p:blipFill>
+        <p:spPr>
+          <a:xfrm>
+            <a:off x="749808" y="722376"/>
+            <a:ext cx="1828800" cy="896112"/>
+          </a:xfrm>
+          <a:prstGeom prst="rect">
+            <a:avLst/>
+          </a:prstGeom>
+        </p:spPr>
+      </p:pic>
+      <p:sp>
+        <p:nvSpPr>
+          <p:cNvPr id="4" name="Text 1"/>
           <p:cNvSpPr/>
           <p:nvPr/>
         </p:nvSpPr>
@@ -2894,7 +2850,7 @@
       </p:sp>
       <p:sp>
         <p:nvSpPr>
-          <p:cNvPr id="5" name="Text 3"/>
+          <p:cNvPr id="5" name="Text 2"/>
           <p:cNvSpPr/>
           <p:nvPr/>
         </p:nvSpPr>
@@ -2933,7 +2889,7 @@
       </p:sp>
       <p:sp>
         <p:nvSpPr>
-          <p:cNvPr id="6" name="Text 4"/>
+          <p:cNvPr id="6" name="Text 3"/>
           <p:cNvSpPr/>
           <p:nvPr/>
         </p:nvSpPr>
@@ -2972,7 +2928,7 @@
       </p:sp>
       <p:sp>
         <p:nvSpPr>
-          <p:cNvPr id="7" name="Text 5"/>
+          <p:cNvPr id="7" name="Text 4"/>
           <p:cNvSpPr/>
           <p:nvPr/>
         </p:nvSpPr>
@@ -3011,7 +2967,7 @@
       </p:sp>
       <p:sp>
         <p:nvSpPr>
-          <p:cNvPr id="8" name="Text 6"/>
+          <p:cNvPr id="8" name="Text 5"/>
           <p:cNvSpPr/>
           <p:nvPr/>
         </p:nvSpPr>
@@ -3050,7 +3006,7 @@
       </p:sp>
       <p:sp>
         <p:nvSpPr>
-          <p:cNvPr id="9" name="Shape 7"/>
+          <p:cNvPr id="9" name="Shape 6"/>
           <p:cNvSpPr/>
           <p:nvPr/>
         </p:nvSpPr>
@@ -3077,7 +3033,7 @@
       </p:sp>
       <p:sp>
         <p:nvSpPr>
-          <p:cNvPr id="10" name="Text 8"/>
+          <p:cNvPr id="10" name="Text 7"/>
           <p:cNvSpPr/>
           <p:nvPr/>
         </p:nvSpPr>
@@ -3119,7 +3075,7 @@
       </p:sp>
       <p:sp>
         <p:nvSpPr>
-          <p:cNvPr id="11" name="Shape 9"/>
+          <p:cNvPr id="11" name="Shape 8"/>
           <p:cNvSpPr/>
           <p:nvPr/>
         </p:nvSpPr>
@@ -3146,7 +3102,7 @@
       </p:sp>
       <p:sp>
         <p:nvSpPr>
-          <p:cNvPr id="12" name="Text 10"/>
+          <p:cNvPr id="12" name="Text 9"/>
           <p:cNvSpPr/>
           <p:nvPr/>
         </p:nvSpPr>
@@ -3188,7 +3144,7 @@
       </p:sp>
       <p:sp>
         <p:nvSpPr>
-          <p:cNvPr id="13" name="Shape 11"/>
+          <p:cNvPr id="13" name="Shape 10"/>
           <p:cNvSpPr/>
           <p:nvPr/>
         </p:nvSpPr>
@@ -3215,7 +3171,7 @@
       </p:sp>
       <p:sp>
         <p:nvSpPr>
-          <p:cNvPr id="14" name="Text 12"/>
+          <p:cNvPr id="14" name="Text 11"/>
           <p:cNvSpPr/>
           <p:nvPr/>
         </p:nvSpPr>
@@ -3257,7 +3213,7 @@
       </p:sp>
       <p:sp>
         <p:nvSpPr>
-          <p:cNvPr id="15" name="Shape 13"/>
+          <p:cNvPr id="15" name="Shape 12"/>
           <p:cNvSpPr/>
           <p:nvPr/>
         </p:nvSpPr>
@@ -3284,7 +3240,7 @@
       </p:sp>
       <p:sp>
         <p:nvSpPr>
-          <p:cNvPr id="16" name="Text 14"/>
+          <p:cNvPr id="16" name="Text 13"/>
           <p:cNvSpPr/>
           <p:nvPr/>
         </p:nvSpPr>

</xml_diff>